<commit_message>
docs: refine project status report visuals
Co-authored-by: 程序员鱼皮 <592789970@qq.com>
</commit_message>
<xml_diff>
--- a/docs/reports/project-status-2026-06-28.pptx
+++ b/docs/reports/project-status-2026-06-28.pptx
@@ -1793,6 +1793,10 @@
             <a:prstDash val="solid"/>
           </a:ln>
         </p:spPr>
+        <p:txBody>
+          <a:bodyPr/>
+          <a:p/>
+        </p:txBody>
       </p:sp>
       <p:sp>
         <p:nvSpPr>
@@ -1822,6 +1826,10 @@
             <a:prstDash val="solid"/>
           </a:ln>
         </p:spPr>
+        <p:txBody>
+          <a:bodyPr/>
+          <a:p/>
+        </p:txBody>
       </p:sp>
       <p:sp>
         <p:nvSpPr>
@@ -1851,6 +1859,10 @@
             <a:prstDash val="solid"/>
           </a:ln>
         </p:spPr>
+        <p:txBody>
+          <a:bodyPr/>
+          <a:p/>
+        </p:txBody>
       </p:sp>
       <p:sp>
         <p:nvSpPr>
@@ -1878,6 +1890,10 @@
             <a:prstDash val="solid"/>
           </a:ln>
         </p:spPr>
+        <p:txBody>
+          <a:bodyPr/>
+          <a:p/>
+        </p:txBody>
       </p:sp>
       <p:sp>
         <p:nvSpPr>
@@ -2117,6 +2133,10 @@
             </a:outerShdw>
           </a:effectLst>
         </p:spPr>
+        <p:txBody>
+          <a:bodyPr/>
+          <a:p/>
+        </p:txBody>
       </p:sp>
       <p:sp>
         <p:nvSpPr>
@@ -2144,6 +2164,10 @@
             <a:prstDash val="solid"/>
           </a:ln>
         </p:spPr>
+        <p:txBody>
+          <a:bodyPr/>
+          <a:p/>
+        </p:txBody>
       </p:sp>
       <p:sp>
         <p:nvSpPr>
@@ -2215,7 +2239,7 @@
             <a:r>
               <a:rPr lang="en-US" sz="1500" b="1" dirty="0">
                 <a:solidFill>
-                  <a:srgbClr val="FFFFFF"/>
+                  <a:srgbClr val="065A82"/>
                 </a:solidFill>
                 <a:latin typeface="Calibri" pitchFamily="34" charset="0"/>
                 <a:ea typeface="Calibri" pitchFamily="34" charset="-122"/>
@@ -2253,6 +2277,10 @@
             <a:prstDash val="solid"/>
           </a:ln>
         </p:spPr>
+        <p:txBody>
+          <a:bodyPr/>
+          <a:p/>
+        </p:txBody>
       </p:sp>
       <p:sp>
         <p:nvSpPr>
@@ -2324,7 +2352,7 @@
             <a:r>
               <a:rPr lang="en-US" sz="1500" b="1" dirty="0">
                 <a:solidFill>
-                  <a:srgbClr val="FFFFFF"/>
+                  <a:srgbClr val="065A82"/>
                 </a:solidFill>
                 <a:latin typeface="Calibri" pitchFamily="34" charset="0"/>
                 <a:ea typeface="Calibri" pitchFamily="34" charset="-122"/>
@@ -2362,6 +2390,10 @@
             <a:prstDash val="solid"/>
           </a:ln>
         </p:spPr>
+        <p:txBody>
+          <a:bodyPr/>
+          <a:p/>
+        </p:txBody>
       </p:sp>
       <p:sp>
         <p:nvSpPr>
@@ -2433,7 +2465,7 @@
             <a:r>
               <a:rPr lang="en-US" sz="1500" b="1" dirty="0">
                 <a:solidFill>
-                  <a:srgbClr val="FFFFFF"/>
+                  <a:srgbClr val="065A82"/>
                 </a:solidFill>
                 <a:latin typeface="Calibri" pitchFamily="34" charset="0"/>
                 <a:ea typeface="Calibri" pitchFamily="34" charset="-122"/>
@@ -2471,6 +2503,10 @@
             <a:prstDash val="solid"/>
           </a:ln>
         </p:spPr>
+        <p:txBody>
+          <a:bodyPr/>
+          <a:p/>
+        </p:txBody>
       </p:sp>
       <p:sp>
         <p:nvSpPr>
@@ -2542,7 +2578,7 @@
             <a:r>
               <a:rPr lang="en-US" sz="1500" b="1" dirty="0">
                 <a:solidFill>
-                  <a:srgbClr val="FFFFFF"/>
+                  <a:srgbClr val="065A82"/>
                 </a:solidFill>
                 <a:latin typeface="Calibri" pitchFamily="34" charset="0"/>
                 <a:ea typeface="Calibri" pitchFamily="34" charset="-122"/>
@@ -2653,6 +2689,10 @@
             <a:prstDash val="solid"/>
           </a:ln>
         </p:spPr>
+        <p:txBody>
+          <a:bodyPr/>
+          <a:p/>
+        </p:txBody>
       </p:sp>
       <p:sp>
         <p:nvSpPr>
@@ -2680,6 +2720,10 @@
             <a:prstDash val="solid"/>
           </a:ln>
         </p:spPr>
+        <p:txBody>
+          <a:bodyPr/>
+          <a:p/>
+        </p:txBody>
       </p:sp>
       <p:sp>
         <p:nvSpPr>
@@ -2709,6 +2753,10 @@
             <a:prstDash val="solid"/>
           </a:ln>
         </p:spPr>
+        <p:txBody>
+          <a:bodyPr/>
+          <a:p/>
+        </p:txBody>
       </p:sp>
       <p:sp>
         <p:nvSpPr>
@@ -2862,6 +2910,10 @@
             </a:outerShdw>
           </a:effectLst>
         </p:spPr>
+        <p:txBody>
+          <a:bodyPr/>
+          <a:p/>
+        </p:txBody>
       </p:sp>
       <p:sp>
         <p:nvSpPr>
@@ -2889,6 +2941,10 @@
             <a:prstDash val="solid"/>
           </a:ln>
         </p:spPr>
+        <p:txBody>
+          <a:bodyPr/>
+          <a:p/>
+        </p:txBody>
       </p:sp>
       <p:sp>
         <p:nvSpPr>
@@ -2998,6 +3054,10 @@
             <a:prstDash val="solid"/>
           </a:ln>
         </p:spPr>
+        <p:txBody>
+          <a:bodyPr/>
+          <a:p/>
+        </p:txBody>
       </p:sp>
       <p:sp>
         <p:nvSpPr>
@@ -3107,6 +3167,10 @@
             <a:prstDash val="solid"/>
           </a:ln>
         </p:spPr>
+        <p:txBody>
+          <a:bodyPr/>
+          <a:p/>
+        </p:txBody>
       </p:sp>
       <p:sp>
         <p:nvSpPr>
@@ -3216,6 +3280,10 @@
             <a:prstDash val="solid"/>
           </a:ln>
         </p:spPr>
+        <p:txBody>
+          <a:bodyPr/>
+          <a:p/>
+        </p:txBody>
       </p:sp>
       <p:sp>
         <p:nvSpPr>
@@ -3332,6 +3400,10 @@
             </a:outerShdw>
           </a:effectLst>
         </p:spPr>
+        <p:txBody>
+          <a:bodyPr/>
+          <a:p/>
+        </p:txBody>
       </p:sp>
       <p:sp>
         <p:nvSpPr>
@@ -3359,6 +3431,10 @@
             <a:prstDash val="solid"/>
           </a:ln>
         </p:spPr>
+        <p:txBody>
+          <a:bodyPr/>
+          <a:p/>
+        </p:txBody>
       </p:sp>
       <p:sp>
         <p:nvSpPr>
@@ -3468,6 +3544,10 @@
             <a:prstDash val="solid"/>
           </a:ln>
         </p:spPr>
+        <p:txBody>
+          <a:bodyPr/>
+          <a:p/>
+        </p:txBody>
       </p:sp>
       <p:sp>
         <p:nvSpPr>
@@ -3577,6 +3657,10 @@
             <a:prstDash val="solid"/>
           </a:ln>
         </p:spPr>
+        <p:txBody>
+          <a:bodyPr/>
+          <a:p/>
+        </p:txBody>
       </p:sp>
       <p:sp>
         <p:nvSpPr>
@@ -3686,6 +3770,10 @@
             <a:prstDash val="solid"/>
           </a:ln>
         </p:spPr>
+        <p:txBody>
+          <a:bodyPr/>
+          <a:p/>
+        </p:txBody>
       </p:sp>
       <p:sp>
         <p:nvSpPr>
@@ -3802,6 +3890,10 @@
             </a:outerShdw>
           </a:effectLst>
         </p:spPr>
+        <p:txBody>
+          <a:bodyPr/>
+          <a:p/>
+        </p:txBody>
       </p:sp>
       <p:sp>
         <p:nvSpPr>
@@ -3829,6 +3921,10 @@
             <a:prstDash val="solid"/>
           </a:ln>
         </p:spPr>
+        <p:txBody>
+          <a:bodyPr/>
+          <a:p/>
+        </p:txBody>
       </p:sp>
       <p:sp>
         <p:nvSpPr>
@@ -3938,6 +4034,10 @@
             <a:prstDash val="solid"/>
           </a:ln>
         </p:spPr>
+        <p:txBody>
+          <a:bodyPr/>
+          <a:p/>
+        </p:txBody>
       </p:sp>
       <p:sp>
         <p:nvSpPr>
@@ -4047,6 +4147,10 @@
             <a:prstDash val="solid"/>
           </a:ln>
         </p:spPr>
+        <p:txBody>
+          <a:bodyPr/>
+          <a:p/>
+        </p:txBody>
       </p:sp>
       <p:sp>
         <p:nvSpPr>
@@ -4156,6 +4260,10 @@
             <a:prstDash val="solid"/>
           </a:ln>
         </p:spPr>
+        <p:txBody>
+          <a:bodyPr/>
+          <a:p/>
+        </p:txBody>
       </p:sp>
       <p:sp>
         <p:nvSpPr>
@@ -4267,6 +4375,10 @@
             <a:prstDash val="solid"/>
           </a:ln>
         </p:spPr>
+        <p:txBody>
+          <a:bodyPr/>
+          <a:p/>
+        </p:txBody>
       </p:sp>
       <p:sp>
         <p:nvSpPr>
@@ -4447,6 +4559,10 @@
             <a:prstDash val="solid"/>
           </a:ln>
         </p:spPr>
+        <p:txBody>
+          <a:bodyPr/>
+          <a:p/>
+        </p:txBody>
       </p:sp>
       <p:sp>
         <p:nvSpPr>
@@ -4476,6 +4592,10 @@
             <a:prstDash val="solid"/>
           </a:ln>
         </p:spPr>
+        <p:txBody>
+          <a:bodyPr/>
+          <a:p/>
+        </p:txBody>
       </p:sp>
       <p:sp>
         <p:nvSpPr>
@@ -4505,6 +4625,10 @@
             <a:prstDash val="solid"/>
           </a:ln>
         </p:spPr>
+        <p:txBody>
+          <a:bodyPr/>
+          <a:p/>
+        </p:txBody>
       </p:sp>
       <p:sp>
         <p:nvSpPr>
@@ -4621,6 +4745,10 @@
             </a:outerShdw>
           </a:effectLst>
         </p:spPr>
+        <p:txBody>
+          <a:bodyPr/>
+          <a:p/>
+        </p:txBody>
       </p:sp>
       <p:sp>
         <p:nvSpPr>
@@ -4648,6 +4776,10 @@
             <a:prstDash val="solid"/>
           </a:ln>
         </p:spPr>
+        <p:txBody>
+          <a:bodyPr/>
+          <a:p/>
+        </p:txBody>
       </p:sp>
       <p:sp>
         <p:nvSpPr>
@@ -4719,7 +4851,7 @@
             <a:r>
               <a:rPr lang="en-US" sz="1650" b="1" dirty="0">
                 <a:solidFill>
-                  <a:srgbClr val="FFFFFF"/>
+                  <a:srgbClr val="065A82"/>
                 </a:solidFill>
                 <a:latin typeface="Georgia" pitchFamily="34" charset="0"/>
                 <a:ea typeface="Georgia" pitchFamily="34" charset="-122"/>
@@ -4760,7 +4892,7 @@
             <a:r>
               <a:rPr lang="en-US" sz="1160" dirty="0">
                 <a:solidFill>
-                  <a:srgbClr val="E6FFFA"/>
+                  <a:srgbClr val="17324D"/>
                 </a:solidFill>
                 <a:latin typeface="Calibri" pitchFamily="34" charset="0"/>
                 <a:ea typeface="Calibri" pitchFamily="34" charset="-122"/>
@@ -4805,6 +4937,10 @@
             </a:outerShdw>
           </a:effectLst>
         </p:spPr>
+        <p:txBody>
+          <a:bodyPr/>
+          <a:p/>
+        </p:txBody>
       </p:sp>
       <p:sp>
         <p:nvSpPr>
@@ -4832,6 +4968,10 @@
             <a:prstDash val="solid"/>
           </a:ln>
         </p:spPr>
+        <p:txBody>
+          <a:bodyPr/>
+          <a:p/>
+        </p:txBody>
       </p:sp>
       <p:sp>
         <p:nvSpPr>
@@ -4903,7 +5043,7 @@
             <a:r>
               <a:rPr lang="en-US" sz="1650" b="1" dirty="0">
                 <a:solidFill>
-                  <a:srgbClr val="FFFFFF"/>
+                  <a:srgbClr val="065A82"/>
                 </a:solidFill>
                 <a:latin typeface="Georgia" pitchFamily="34" charset="0"/>
                 <a:ea typeface="Georgia" pitchFamily="34" charset="-122"/>
@@ -4944,7 +5084,7 @@
             <a:r>
               <a:rPr lang="en-US" sz="1160" dirty="0">
                 <a:solidFill>
-                  <a:srgbClr val="E6FFFA"/>
+                  <a:srgbClr val="17324D"/>
                 </a:solidFill>
                 <a:latin typeface="Calibri" pitchFamily="34" charset="0"/>
                 <a:ea typeface="Calibri" pitchFamily="34" charset="-122"/>
@@ -4989,6 +5129,10 @@
             </a:outerShdw>
           </a:effectLst>
         </p:spPr>
+        <p:txBody>
+          <a:bodyPr/>
+          <a:p/>
+        </p:txBody>
       </p:sp>
       <p:sp>
         <p:nvSpPr>
@@ -5016,6 +5160,10 @@
             <a:prstDash val="solid"/>
           </a:ln>
         </p:spPr>
+        <p:txBody>
+          <a:bodyPr/>
+          <a:p/>
+        </p:txBody>
       </p:sp>
       <p:sp>
         <p:nvSpPr>
@@ -5087,7 +5235,7 @@
             <a:r>
               <a:rPr lang="en-US" sz="1650" b="1" dirty="0">
                 <a:solidFill>
-                  <a:srgbClr val="FFFFFF"/>
+                  <a:srgbClr val="065A82"/>
                 </a:solidFill>
                 <a:latin typeface="Georgia" pitchFamily="34" charset="0"/>
                 <a:ea typeface="Georgia" pitchFamily="34" charset="-122"/>
@@ -5128,7 +5276,7 @@
             <a:r>
               <a:rPr lang="en-US" sz="1160" dirty="0">
                 <a:solidFill>
-                  <a:srgbClr val="E6FFFA"/>
+                  <a:srgbClr val="17324D"/>
                 </a:solidFill>
                 <a:latin typeface="Calibri" pitchFamily="34" charset="0"/>
                 <a:ea typeface="Calibri" pitchFamily="34" charset="-122"/>
@@ -5173,6 +5321,10 @@
             </a:outerShdw>
           </a:effectLst>
         </p:spPr>
+        <p:txBody>
+          <a:bodyPr/>
+          <a:p/>
+        </p:txBody>
       </p:sp>
       <p:sp>
         <p:nvSpPr>
@@ -5200,6 +5352,10 @@
             <a:prstDash val="solid"/>
           </a:ln>
         </p:spPr>
+        <p:txBody>
+          <a:bodyPr/>
+          <a:p/>
+        </p:txBody>
       </p:sp>
       <p:sp>
         <p:nvSpPr>
@@ -5271,7 +5427,7 @@
             <a:r>
               <a:rPr lang="en-US" sz="1650" b="1" dirty="0">
                 <a:solidFill>
-                  <a:srgbClr val="FFFFFF"/>
+                  <a:srgbClr val="065A82"/>
                 </a:solidFill>
                 <a:latin typeface="Georgia" pitchFamily="34" charset="0"/>
                 <a:ea typeface="Georgia" pitchFamily="34" charset="-122"/>
@@ -5312,7 +5468,7 @@
             <a:r>
               <a:rPr lang="en-US" sz="1160" dirty="0">
                 <a:solidFill>
-                  <a:srgbClr val="E6FFFA"/>
+                  <a:srgbClr val="17324D"/>
                 </a:solidFill>
                 <a:latin typeface="Calibri" pitchFamily="34" charset="0"/>
                 <a:ea typeface="Calibri" pitchFamily="34" charset="-122"/>
@@ -5423,6 +5579,10 @@
             <a:prstDash val="solid"/>
           </a:ln>
         </p:spPr>
+        <p:txBody>
+          <a:bodyPr/>
+          <a:p/>
+        </p:txBody>
       </p:sp>
       <p:sp>
         <p:nvSpPr>
@@ -5450,6 +5610,10 @@
             <a:prstDash val="solid"/>
           </a:ln>
         </p:spPr>
+        <p:txBody>
+          <a:bodyPr/>
+          <a:p/>
+        </p:txBody>
       </p:sp>
       <p:sp>
         <p:nvSpPr>
@@ -5479,6 +5643,10 @@
             <a:prstDash val="solid"/>
           </a:ln>
         </p:spPr>
+        <p:txBody>
+          <a:bodyPr/>
+          <a:p/>
+        </p:txBody>
       </p:sp>
       <p:sp>
         <p:nvSpPr>
@@ -5632,6 +5800,10 @@
             </a:outerShdw>
           </a:effectLst>
         </p:spPr>
+        <p:txBody>
+          <a:bodyPr/>
+          <a:p/>
+        </p:txBody>
       </p:sp>
       <p:sp>
         <p:nvSpPr>
@@ -5745,6 +5917,10 @@
             <a:prstDash val="solid"/>
           </a:ln>
         </p:spPr>
+        <p:txBody>
+          <a:bodyPr/>
+          <a:p/>
+        </p:txBody>
       </p:sp>
       <p:sp>
         <p:nvSpPr>
@@ -5811,6 +5987,10 @@
             <a:prstDash val="solid"/>
           </a:ln>
         </p:spPr>
+        <p:txBody>
+          <a:bodyPr/>
+          <a:p/>
+        </p:txBody>
       </p:sp>
       <p:sp>
         <p:nvSpPr>
@@ -5920,6 +6100,10 @@
             <a:prstDash val="solid"/>
           </a:ln>
         </p:spPr>
+        <p:txBody>
+          <a:bodyPr/>
+          <a:p/>
+        </p:txBody>
       </p:sp>
       <p:sp>
         <p:nvSpPr>
@@ -6029,6 +6213,10 @@
             <a:prstDash val="solid"/>
           </a:ln>
         </p:spPr>
+        <p:txBody>
+          <a:bodyPr/>
+          <a:p/>
+        </p:txBody>
       </p:sp>
       <p:sp>
         <p:nvSpPr>
@@ -6145,6 +6333,10 @@
             </a:outerShdw>
           </a:effectLst>
         </p:spPr>
+        <p:txBody>
+          <a:bodyPr/>
+          <a:p/>
+        </p:txBody>
       </p:sp>
       <p:sp>
         <p:nvSpPr>
@@ -6298,6 +6490,10 @@
             </a:outerShdw>
           </a:effectLst>
         </p:spPr>
+        <p:txBody>
+          <a:bodyPr/>
+          <a:p/>
+        </p:txBody>
       </p:sp>
       <p:sp>
         <p:nvSpPr>
@@ -6451,6 +6647,10 @@
             </a:outerShdw>
           </a:effectLst>
         </p:spPr>
+        <p:txBody>
+          <a:bodyPr/>
+          <a:p/>
+        </p:txBody>
       </p:sp>
       <p:sp>
         <p:nvSpPr>
@@ -6604,6 +6804,10 @@
             </a:outerShdw>
           </a:effectLst>
         </p:spPr>
+        <p:txBody>
+          <a:bodyPr/>
+          <a:p/>
+        </p:txBody>
       </p:sp>
       <p:sp>
         <p:nvSpPr>
@@ -6750,6 +6954,10 @@
             <a:prstDash val="solid"/>
           </a:ln>
         </p:spPr>
+        <p:txBody>
+          <a:bodyPr/>
+          <a:p/>
+        </p:txBody>
       </p:sp>
       <p:sp>
         <p:nvSpPr>
@@ -6928,6 +7136,10 @@
             <a:prstDash val="solid"/>
           </a:ln>
         </p:spPr>
+        <p:txBody>
+          <a:bodyPr/>
+          <a:p/>
+        </p:txBody>
       </p:sp>
       <p:sp>
         <p:nvSpPr>
@@ -6955,6 +7167,10 @@
             <a:prstDash val="solid"/>
           </a:ln>
         </p:spPr>
+        <p:txBody>
+          <a:bodyPr/>
+          <a:p/>
+        </p:txBody>
       </p:sp>
       <p:sp>
         <p:nvSpPr>
@@ -6984,6 +7200,10 @@
             <a:prstDash val="solid"/>
           </a:ln>
         </p:spPr>
+        <p:txBody>
+          <a:bodyPr/>
+          <a:p/>
+        </p:txBody>
       </p:sp>
       <p:sp>
         <p:nvSpPr>
@@ -7137,6 +7357,10 @@
             </a:outerShdw>
           </a:effectLst>
         </p:spPr>
+        <p:txBody>
+          <a:bodyPr/>
+          <a:p/>
+        </p:txBody>
       </p:sp>
       <p:sp>
         <p:nvSpPr>
@@ -7164,6 +7388,10 @@
             <a:prstDash val="solid"/>
           </a:ln>
         </p:spPr>
+        <p:txBody>
+          <a:bodyPr/>
+          <a:p/>
+        </p:txBody>
       </p:sp>
       <p:sp>
         <p:nvSpPr>
@@ -7321,6 +7549,10 @@
             </a:outerShdw>
           </a:effectLst>
         </p:spPr>
+        <p:txBody>
+          <a:bodyPr/>
+          <a:p/>
+        </p:txBody>
       </p:sp>
       <p:sp>
         <p:nvSpPr>
@@ -7348,6 +7580,10 @@
             <a:prstDash val="solid"/>
           </a:ln>
         </p:spPr>
+        <p:txBody>
+          <a:bodyPr/>
+          <a:p/>
+        </p:txBody>
       </p:sp>
       <p:sp>
         <p:nvSpPr>
@@ -7505,6 +7741,10 @@
             </a:outerShdw>
           </a:effectLst>
         </p:spPr>
+        <p:txBody>
+          <a:bodyPr/>
+          <a:p/>
+        </p:txBody>
       </p:sp>
       <p:sp>
         <p:nvSpPr>
@@ -7532,6 +7772,10 @@
             <a:prstDash val="solid"/>
           </a:ln>
         </p:spPr>
+        <p:txBody>
+          <a:bodyPr/>
+          <a:p/>
+        </p:txBody>
       </p:sp>
       <p:sp>
         <p:nvSpPr>
@@ -7689,6 +7933,10 @@
             </a:outerShdw>
           </a:effectLst>
         </p:spPr>
+        <p:txBody>
+          <a:bodyPr/>
+          <a:p/>
+        </p:txBody>
       </p:sp>
       <p:sp>
         <p:nvSpPr>
@@ -7716,6 +7964,10 @@
             <a:prstDash val="solid"/>
           </a:ln>
         </p:spPr>
+        <p:txBody>
+          <a:bodyPr/>
+          <a:p/>
+        </p:txBody>
       </p:sp>
       <p:sp>
         <p:nvSpPr>
@@ -7873,6 +8125,10 @@
             </a:outerShdw>
           </a:effectLst>
         </p:spPr>
+        <p:txBody>
+          <a:bodyPr/>
+          <a:p/>
+        </p:txBody>
       </p:sp>
       <p:sp>
         <p:nvSpPr>
@@ -7900,6 +8156,10 @@
             <a:prstDash val="solid"/>
           </a:ln>
         </p:spPr>
+        <p:txBody>
+          <a:bodyPr/>
+          <a:p/>
+        </p:txBody>
       </p:sp>
       <p:sp>
         <p:nvSpPr>
@@ -8057,6 +8317,10 @@
             </a:outerShdw>
           </a:effectLst>
         </p:spPr>
+        <p:txBody>
+          <a:bodyPr/>
+          <a:p/>
+        </p:txBody>
       </p:sp>
       <p:sp>
         <p:nvSpPr>
@@ -8084,6 +8348,10 @@
             <a:prstDash val="solid"/>
           </a:ln>
         </p:spPr>
+        <p:txBody>
+          <a:bodyPr/>
+          <a:p/>
+        </p:txBody>
       </p:sp>
       <p:sp>
         <p:nvSpPr>
@@ -8236,6 +8504,10 @@
             <a:prstDash val="solid"/>
           </a:ln>
         </p:spPr>
+        <p:txBody>
+          <a:bodyPr/>
+          <a:p/>
+        </p:txBody>
       </p:sp>
       <p:sp>
         <p:nvSpPr>
@@ -8414,6 +8686,10 @@
             <a:prstDash val="solid"/>
           </a:ln>
         </p:spPr>
+        <p:txBody>
+          <a:bodyPr/>
+          <a:p/>
+        </p:txBody>
       </p:sp>
       <p:sp>
         <p:nvSpPr>
@@ -8441,6 +8717,10 @@
             <a:prstDash val="solid"/>
           </a:ln>
         </p:spPr>
+        <p:txBody>
+          <a:bodyPr/>
+          <a:p/>
+        </p:txBody>
       </p:sp>
       <p:sp>
         <p:nvSpPr>
@@ -8470,6 +8750,10 @@
             <a:prstDash val="solid"/>
           </a:ln>
         </p:spPr>
+        <p:txBody>
+          <a:bodyPr/>
+          <a:p/>
+        </p:txBody>
       </p:sp>
       <p:sp>
         <p:nvSpPr>
@@ -8623,6 +8907,10 @@
             </a:outerShdw>
           </a:effectLst>
         </p:spPr>
+        <p:txBody>
+          <a:bodyPr/>
+          <a:p/>
+        </p:txBody>
       </p:sp>
       <p:sp>
         <p:nvSpPr>
@@ -8691,6 +8979,10 @@
             <a:prstDash val="solid"/>
           </a:ln>
         </p:spPr>
+        <p:txBody>
+          <a:bodyPr/>
+          <a:p/>
+        </p:txBody>
       </p:sp>
       <p:sp>
         <p:nvSpPr>
@@ -8800,6 +9092,10 @@
             <a:prstDash val="solid"/>
           </a:ln>
         </p:spPr>
+        <p:txBody>
+          <a:bodyPr/>
+          <a:p/>
+        </p:txBody>
       </p:sp>
       <p:sp>
         <p:nvSpPr>
@@ -8909,6 +9205,10 @@
             <a:prstDash val="solid"/>
           </a:ln>
         </p:spPr>
+        <p:txBody>
+          <a:bodyPr/>
+          <a:p/>
+        </p:txBody>
       </p:sp>
       <p:sp>
         <p:nvSpPr>
@@ -9018,6 +9318,10 @@
             <a:prstDash val="solid"/>
           </a:ln>
         </p:spPr>
+        <p:txBody>
+          <a:bodyPr/>
+          <a:p/>
+        </p:txBody>
       </p:sp>
       <p:sp>
         <p:nvSpPr>
@@ -9127,6 +9431,10 @@
             <a:prstDash val="solid"/>
           </a:ln>
         </p:spPr>
+        <p:txBody>
+          <a:bodyPr/>
+          <a:p/>
+        </p:txBody>
       </p:sp>
       <p:sp>
         <p:nvSpPr>
@@ -9243,6 +9551,10 @@
             </a:outerShdw>
           </a:effectLst>
         </p:spPr>
+        <p:txBody>
+          <a:bodyPr/>
+          <a:p/>
+        </p:txBody>
       </p:sp>
       <p:sp>
         <p:nvSpPr>
@@ -9359,6 +9671,10 @@
             </a:outerShdw>
           </a:effectLst>
         </p:spPr>
+        <p:txBody>
+          <a:bodyPr/>
+          <a:p/>
+        </p:txBody>
       </p:sp>
       <p:sp>
         <p:nvSpPr>
@@ -9465,6 +9781,10 @@
             <a:tailEnd type="triangle"/>
           </a:ln>
         </p:spPr>
+        <p:txBody>
+          <a:bodyPr/>
+          <a:p/>
+        </p:txBody>
       </p:sp>
       <p:sp>
         <p:nvSpPr>
@@ -9489,6 +9809,10 @@
             <a:tailEnd type="triangle"/>
           </a:ln>
         </p:spPr>
+        <p:txBody>
+          <a:bodyPr/>
+          <a:p/>
+        </p:txBody>
       </p:sp>
       <p:sp>
         <p:nvSpPr>
@@ -9626,6 +9950,10 @@
             <a:prstDash val="solid"/>
           </a:ln>
         </p:spPr>
+        <p:txBody>
+          <a:bodyPr/>
+          <a:p/>
+        </p:txBody>
       </p:sp>
       <p:sp>
         <p:nvSpPr>
@@ -9653,6 +9981,10 @@
             <a:prstDash val="solid"/>
           </a:ln>
         </p:spPr>
+        <p:txBody>
+          <a:bodyPr/>
+          <a:p/>
+        </p:txBody>
       </p:sp>
       <p:sp>
         <p:nvSpPr>
@@ -9682,6 +10014,10 @@
             <a:prstDash val="solid"/>
           </a:ln>
         </p:spPr>
+        <p:txBody>
+          <a:bodyPr/>
+          <a:p/>
+        </p:txBody>
       </p:sp>
       <p:sp>
         <p:nvSpPr>
@@ -9835,6 +10171,10 @@
             </a:outerShdw>
           </a:effectLst>
         </p:spPr>
+        <p:txBody>
+          <a:bodyPr/>
+          <a:p/>
+        </p:txBody>
       </p:sp>
       <p:sp>
         <p:nvSpPr>
@@ -9862,6 +10202,10 @@
             <a:prstDash val="solid"/>
           </a:ln>
         </p:spPr>
+        <p:txBody>
+          <a:bodyPr/>
+          <a:p/>
+        </p:txBody>
       </p:sp>
       <p:sp>
         <p:nvSpPr>
@@ -10009,6 +10353,10 @@
             <a:tailEnd type="triangle"/>
           </a:ln>
         </p:spPr>
+        <p:txBody>
+          <a:bodyPr/>
+          <a:p/>
+        </p:txBody>
       </p:sp>
       <p:sp>
         <p:nvSpPr>
@@ -10043,6 +10391,10 @@
             </a:outerShdw>
           </a:effectLst>
         </p:spPr>
+        <p:txBody>
+          <a:bodyPr/>
+          <a:p/>
+        </p:txBody>
       </p:sp>
       <p:sp>
         <p:nvSpPr>
@@ -10070,6 +10422,10 @@
             <a:prstDash val="solid"/>
           </a:ln>
         </p:spPr>
+        <p:txBody>
+          <a:bodyPr/>
+          <a:p/>
+        </p:txBody>
       </p:sp>
       <p:sp>
         <p:nvSpPr>
@@ -10217,6 +10573,10 @@
             <a:tailEnd type="triangle"/>
           </a:ln>
         </p:spPr>
+        <p:txBody>
+          <a:bodyPr/>
+          <a:p/>
+        </p:txBody>
       </p:sp>
       <p:sp>
         <p:nvSpPr>
@@ -10251,6 +10611,10 @@
             </a:outerShdw>
           </a:effectLst>
         </p:spPr>
+        <p:txBody>
+          <a:bodyPr/>
+          <a:p/>
+        </p:txBody>
       </p:sp>
       <p:sp>
         <p:nvSpPr>
@@ -10278,6 +10642,10 @@
             <a:prstDash val="solid"/>
           </a:ln>
         </p:spPr>
+        <p:txBody>
+          <a:bodyPr/>
+          <a:p/>
+        </p:txBody>
       </p:sp>
       <p:sp>
         <p:nvSpPr>
@@ -10425,6 +10793,10 @@
             <a:tailEnd type="triangle"/>
           </a:ln>
         </p:spPr>
+        <p:txBody>
+          <a:bodyPr/>
+          <a:p/>
+        </p:txBody>
       </p:sp>
       <p:sp>
         <p:nvSpPr>
@@ -10459,6 +10831,10 @@
             </a:outerShdw>
           </a:effectLst>
         </p:spPr>
+        <p:txBody>
+          <a:bodyPr/>
+          <a:p/>
+        </p:txBody>
       </p:sp>
       <p:sp>
         <p:nvSpPr>
@@ -10486,6 +10862,10 @@
             <a:prstDash val="solid"/>
           </a:ln>
         </p:spPr>
+        <p:txBody>
+          <a:bodyPr/>
+          <a:p/>
+        </p:txBody>
       </p:sp>
       <p:sp>
         <p:nvSpPr>
@@ -10633,6 +11013,10 @@
             <a:tailEnd type="triangle"/>
           </a:ln>
         </p:spPr>
+        <p:txBody>
+          <a:bodyPr/>
+          <a:p/>
+        </p:txBody>
       </p:sp>
       <p:sp>
         <p:nvSpPr>
@@ -10667,6 +11051,10 @@
             </a:outerShdw>
           </a:effectLst>
         </p:spPr>
+        <p:txBody>
+          <a:bodyPr/>
+          <a:p/>
+        </p:txBody>
       </p:sp>
       <p:sp>
         <p:nvSpPr>
@@ -10694,6 +11082,10 @@
             <a:prstDash val="solid"/>
           </a:ln>
         </p:spPr>
+        <p:txBody>
+          <a:bodyPr/>
+          <a:p/>
+        </p:txBody>
       </p:sp>
       <p:sp>
         <p:nvSpPr>
@@ -10846,6 +11238,10 @@
             <a:prstDash val="solid"/>
           </a:ln>
         </p:spPr>
+        <p:txBody>
+          <a:bodyPr/>
+          <a:p/>
+        </p:txBody>
       </p:sp>
       <p:sp>
         <p:nvSpPr>
@@ -11024,6 +11420,10 @@
             <a:prstDash val="solid"/>
           </a:ln>
         </p:spPr>
+        <p:txBody>
+          <a:bodyPr/>
+          <a:p/>
+        </p:txBody>
       </p:sp>
       <p:sp>
         <p:nvSpPr>
@@ -11051,6 +11451,10 @@
             <a:prstDash val="solid"/>
           </a:ln>
         </p:spPr>
+        <p:txBody>
+          <a:bodyPr/>
+          <a:p/>
+        </p:txBody>
       </p:sp>
       <p:sp>
         <p:nvSpPr>
@@ -11080,6 +11484,10 @@
             <a:prstDash val="solid"/>
           </a:ln>
         </p:spPr>
+        <p:txBody>
+          <a:bodyPr/>
+          <a:p/>
+        </p:txBody>
       </p:sp>
       <p:sp>
         <p:nvSpPr>
@@ -11233,6 +11641,10 @@
             </a:outerShdw>
           </a:effectLst>
         </p:spPr>
+        <p:txBody>
+          <a:bodyPr/>
+          <a:p/>
+        </p:txBody>
       </p:sp>
       <p:sp>
         <p:nvSpPr>
@@ -11349,6 +11761,10 @@
             </a:outerShdw>
           </a:effectLst>
         </p:spPr>
+        <p:txBody>
+          <a:bodyPr/>
+          <a:p/>
+        </p:txBody>
       </p:sp>
       <p:sp>
         <p:nvSpPr>
@@ -11502,6 +11918,10 @@
             </a:outerShdw>
           </a:effectLst>
         </p:spPr>
+        <p:txBody>
+          <a:bodyPr/>
+          <a:p/>
+        </p:txBody>
       </p:sp>
       <p:sp>
         <p:nvSpPr>
@@ -11655,6 +12075,10 @@
             </a:outerShdw>
           </a:effectLst>
         </p:spPr>
+        <p:txBody>
+          <a:bodyPr/>
+          <a:p/>
+        </p:txBody>
       </p:sp>
       <p:sp>
         <p:nvSpPr>
@@ -11682,6 +12106,10 @@
             <a:prstDash val="solid"/>
           </a:ln>
         </p:spPr>
+        <p:txBody>
+          <a:bodyPr/>
+          <a:p/>
+        </p:txBody>
       </p:sp>
       <p:sp>
         <p:nvSpPr>
@@ -11832,6 +12260,10 @@
             <a:prstDash val="solid"/>
           </a:ln>
         </p:spPr>
+        <p:txBody>
+          <a:bodyPr/>
+          <a:p/>
+        </p:txBody>
       </p:sp>
       <p:sp>
         <p:nvSpPr>
@@ -11982,6 +12414,10 @@
             <a:prstDash val="solid"/>
           </a:ln>
         </p:spPr>
+        <p:txBody>
+          <a:bodyPr/>
+          <a:p/>
+        </p:txBody>
       </p:sp>
       <p:sp>
         <p:nvSpPr>
@@ -12132,6 +12568,10 @@
             <a:prstDash val="solid"/>
           </a:ln>
         </p:spPr>
+        <p:txBody>
+          <a:bodyPr/>
+          <a:p/>
+        </p:txBody>
       </p:sp>
       <p:sp>
         <p:nvSpPr>
@@ -12433,6 +12873,10 @@
             <a:prstDash val="solid"/>
           </a:ln>
         </p:spPr>
+        <p:txBody>
+          <a:bodyPr/>
+          <a:p/>
+        </p:txBody>
       </p:sp>
       <p:sp>
         <p:nvSpPr>
@@ -12460,6 +12904,10 @@
             <a:prstDash val="solid"/>
           </a:ln>
         </p:spPr>
+        <p:txBody>
+          <a:bodyPr/>
+          <a:p/>
+        </p:txBody>
       </p:sp>
       <p:sp>
         <p:nvSpPr>
@@ -12489,6 +12937,10 @@
             <a:prstDash val="solid"/>
           </a:ln>
         </p:spPr>
+        <p:txBody>
+          <a:bodyPr/>
+          <a:p/>
+        </p:txBody>
       </p:sp>
       <p:sp>
         <p:nvSpPr>
@@ -12642,6 +13094,10 @@
             </a:outerShdw>
           </a:effectLst>
         </p:spPr>
+        <p:txBody>
+          <a:bodyPr/>
+          <a:p/>
+        </p:txBody>
       </p:sp>
       <p:sp>
         <p:nvSpPr>
@@ -12795,6 +13251,10 @@
             </a:outerShdw>
           </a:effectLst>
         </p:spPr>
+        <p:txBody>
+          <a:bodyPr/>
+          <a:p/>
+        </p:txBody>
       </p:sp>
       <p:sp>
         <p:nvSpPr>
@@ -12948,6 +13408,10 @@
             </a:outerShdw>
           </a:effectLst>
         </p:spPr>
+        <p:txBody>
+          <a:bodyPr/>
+          <a:p/>
+        </p:txBody>
       </p:sp>
       <p:sp>
         <p:nvSpPr>
@@ -13101,6 +13565,10 @@
             </a:outerShdw>
           </a:effectLst>
         </p:spPr>
+        <p:txBody>
+          <a:bodyPr/>
+          <a:p/>
+        </p:txBody>
       </p:sp>
       <p:sp>
         <p:nvSpPr>
@@ -13254,6 +13722,10 @@
             </a:outerShdw>
           </a:effectLst>
         </p:spPr>
+        <p:txBody>
+          <a:bodyPr/>
+          <a:p/>
+        </p:txBody>
       </p:sp>
       <p:sp>
         <p:nvSpPr>
@@ -13322,6 +13794,10 @@
             <a:prstDash val="solid"/>
           </a:ln>
         </p:spPr>
+        <p:txBody>
+          <a:bodyPr/>
+          <a:p/>
+        </p:txBody>
       </p:sp>
       <p:sp>
         <p:nvSpPr>
@@ -13431,6 +13907,10 @@
             <a:prstDash val="solid"/>
           </a:ln>
         </p:spPr>
+        <p:txBody>
+          <a:bodyPr/>
+          <a:p/>
+        </p:txBody>
       </p:sp>
       <p:sp>
         <p:nvSpPr>
@@ -13540,6 +14020,10 @@
             <a:prstDash val="solid"/>
           </a:ln>
         </p:spPr>
+        <p:txBody>
+          <a:bodyPr/>
+          <a:p/>
+        </p:txBody>
       </p:sp>
       <p:sp>
         <p:nvSpPr>
@@ -13649,6 +14133,10 @@
             <a:prstDash val="solid"/>
           </a:ln>
         </p:spPr>
+        <p:txBody>
+          <a:bodyPr/>
+          <a:p/>
+        </p:txBody>
       </p:sp>
       <p:sp>
         <p:nvSpPr>
@@ -13765,6 +14253,10 @@
             </a:outerShdw>
           </a:effectLst>
         </p:spPr>
+        <p:txBody>
+          <a:bodyPr/>
+          <a:p/>
+        </p:txBody>
       </p:sp>
       <p:sp>
         <p:nvSpPr>
@@ -13833,6 +14325,10 @@
             <a:prstDash val="solid"/>
           </a:ln>
         </p:spPr>
+        <p:txBody>
+          <a:bodyPr/>
+          <a:p/>
+        </p:txBody>
       </p:sp>
       <p:sp>
         <p:nvSpPr>
@@ -13860,6 +14356,10 @@
             <a:prstDash val="solid"/>
           </a:ln>
         </p:spPr>
+        <p:txBody>
+          <a:bodyPr/>
+          <a:p/>
+        </p:txBody>
       </p:sp>
       <p:sp>
         <p:nvSpPr>
@@ -13969,6 +14469,10 @@
             <a:prstDash val="solid"/>
           </a:ln>
         </p:spPr>
+        <p:txBody>
+          <a:bodyPr/>
+          <a:p/>
+        </p:txBody>
       </p:sp>
       <p:sp>
         <p:nvSpPr>
@@ -13996,6 +14500,10 @@
             <a:prstDash val="solid"/>
           </a:ln>
         </p:spPr>
+        <p:txBody>
+          <a:bodyPr/>
+          <a:p/>
+        </p:txBody>
       </p:sp>
       <p:sp>
         <p:nvSpPr>
@@ -14105,6 +14613,10 @@
             <a:prstDash val="solid"/>
           </a:ln>
         </p:spPr>
+        <p:txBody>
+          <a:bodyPr/>
+          <a:p/>
+        </p:txBody>
       </p:sp>
       <p:sp>
         <p:nvSpPr>
@@ -14132,6 +14644,10 @@
             <a:prstDash val="solid"/>
           </a:ln>
         </p:spPr>
+        <p:txBody>
+          <a:bodyPr/>
+          <a:p/>
+        </p:txBody>
       </p:sp>
       <p:sp>
         <p:nvSpPr>
@@ -14351,6 +14867,10 @@
             <a:prstDash val="solid"/>
           </a:ln>
         </p:spPr>
+        <p:txBody>
+          <a:bodyPr/>
+          <a:p/>
+        </p:txBody>
       </p:sp>
       <p:sp>
         <p:nvSpPr>
@@ -14378,6 +14898,10 @@
             <a:prstDash val="solid"/>
           </a:ln>
         </p:spPr>
+        <p:txBody>
+          <a:bodyPr/>
+          <a:p/>
+        </p:txBody>
       </p:sp>
       <p:sp>
         <p:nvSpPr>
@@ -14407,6 +14931,10 @@
             <a:prstDash val="solid"/>
           </a:ln>
         </p:spPr>
+        <p:txBody>
+          <a:bodyPr/>
+          <a:p/>
+        </p:txBody>
       </p:sp>
       <p:sp>
         <p:nvSpPr>
@@ -14553,6 +15081,10 @@
             <a:prstDash val="solid"/>
           </a:ln>
         </p:spPr>
+        <p:txBody>
+          <a:bodyPr/>
+          <a:p/>
+        </p:txBody>
       </p:sp>
       <p:sp>
         <p:nvSpPr>
@@ -14580,6 +15112,10 @@
             <a:prstDash val="solid"/>
           </a:ln>
         </p:spPr>
+        <p:txBody>
+          <a:bodyPr/>
+          <a:p/>
+        </p:txBody>
       </p:sp>
       <p:sp>
         <p:nvSpPr>
@@ -14730,6 +15266,10 @@
             <a:prstDash val="solid"/>
           </a:ln>
         </p:spPr>
+        <p:txBody>
+          <a:bodyPr/>
+          <a:p/>
+        </p:txBody>
       </p:sp>
       <p:sp>
         <p:nvSpPr>
@@ -14757,6 +15297,10 @@
             <a:prstDash val="solid"/>
           </a:ln>
         </p:spPr>
+        <p:txBody>
+          <a:bodyPr/>
+          <a:p/>
+        </p:txBody>
       </p:sp>
       <p:sp>
         <p:nvSpPr>
@@ -14907,6 +15451,10 @@
             <a:prstDash val="solid"/>
           </a:ln>
         </p:spPr>
+        <p:txBody>
+          <a:bodyPr/>
+          <a:p/>
+        </p:txBody>
       </p:sp>
       <p:sp>
         <p:nvSpPr>
@@ -14934,6 +15482,10 @@
             <a:prstDash val="solid"/>
           </a:ln>
         </p:spPr>
+        <p:txBody>
+          <a:bodyPr/>
+          <a:p/>
+        </p:txBody>
       </p:sp>
       <p:sp>
         <p:nvSpPr>
@@ -15084,6 +15636,10 @@
             <a:prstDash val="solid"/>
           </a:ln>
         </p:spPr>
+        <p:txBody>
+          <a:bodyPr/>
+          <a:p/>
+        </p:txBody>
       </p:sp>
       <p:sp>
         <p:nvSpPr>
@@ -15111,6 +15667,10 @@
             <a:prstDash val="solid"/>
           </a:ln>
         </p:spPr>
+        <p:txBody>
+          <a:bodyPr/>
+          <a:p/>
+        </p:txBody>
       </p:sp>
       <p:sp>
         <p:nvSpPr>
@@ -15261,6 +15821,10 @@
             <a:prstDash val="solid"/>
           </a:ln>
         </p:spPr>
+        <p:txBody>
+          <a:bodyPr/>
+          <a:p/>
+        </p:txBody>
       </p:sp>
       <p:sp>
         <p:nvSpPr>
@@ -15288,6 +15852,10 @@
             <a:prstDash val="solid"/>
           </a:ln>
         </p:spPr>
+        <p:txBody>
+          <a:bodyPr/>
+          <a:p/>
+        </p:txBody>
       </p:sp>
       <p:sp>
         <p:nvSpPr>
@@ -15440,6 +16008,10 @@
             <a:prstDash val="solid"/>
           </a:ln>
         </p:spPr>
+        <p:txBody>
+          <a:bodyPr/>
+          <a:p/>
+        </p:txBody>
       </p:sp>
       <p:sp>
         <p:nvSpPr>
@@ -15618,6 +16190,10 @@
             <a:prstDash val="solid"/>
           </a:ln>
         </p:spPr>
+        <p:txBody>
+          <a:bodyPr/>
+          <a:p/>
+        </p:txBody>
       </p:sp>
       <p:sp>
         <p:nvSpPr>
@@ -15645,6 +16221,10 @@
             <a:prstDash val="solid"/>
           </a:ln>
         </p:spPr>
+        <p:txBody>
+          <a:bodyPr/>
+          <a:p/>
+        </p:txBody>
       </p:sp>
       <p:sp>
         <p:nvSpPr>
@@ -15674,6 +16254,10 @@
             <a:prstDash val="solid"/>
           </a:ln>
         </p:spPr>
+        <p:txBody>
+          <a:bodyPr/>
+          <a:p/>
+        </p:txBody>
       </p:sp>
       <p:sp>
         <p:nvSpPr>
@@ -15827,6 +16411,10 @@
             </a:outerShdw>
           </a:effectLst>
         </p:spPr>
+        <p:txBody>
+          <a:bodyPr/>
+          <a:p/>
+        </p:txBody>
       </p:sp>
       <p:sp>
         <p:nvSpPr>
@@ -15858,6 +16446,10 @@
             <a:prstDash val="solid"/>
           </a:ln>
         </p:spPr>
+        <p:txBody>
+          <a:bodyPr/>
+          <a:p/>
+        </p:txBody>
       </p:sp>
       <p:sp>
         <p:nvSpPr>
@@ -16013,6 +16605,10 @@
             </a:outerShdw>
           </a:effectLst>
         </p:spPr>
+        <p:txBody>
+          <a:bodyPr/>
+          <a:p/>
+        </p:txBody>
       </p:sp>
       <p:sp>
         <p:nvSpPr>
@@ -16044,6 +16640,10 @@
             <a:prstDash val="solid"/>
           </a:ln>
         </p:spPr>
+        <p:txBody>
+          <a:bodyPr/>
+          <a:p/>
+        </p:txBody>
       </p:sp>
       <p:sp>
         <p:nvSpPr>
@@ -16199,6 +16799,10 @@
             </a:outerShdw>
           </a:effectLst>
         </p:spPr>
+        <p:txBody>
+          <a:bodyPr/>
+          <a:p/>
+        </p:txBody>
       </p:sp>
       <p:sp>
         <p:nvSpPr>
@@ -16230,6 +16834,10 @@
             <a:prstDash val="solid"/>
           </a:ln>
         </p:spPr>
+        <p:txBody>
+          <a:bodyPr/>
+          <a:p/>
+        </p:txBody>
       </p:sp>
       <p:sp>
         <p:nvSpPr>
@@ -16385,6 +16993,10 @@
             </a:outerShdw>
           </a:effectLst>
         </p:spPr>
+        <p:txBody>
+          <a:bodyPr/>
+          <a:p/>
+        </p:txBody>
       </p:sp>
       <p:sp>
         <p:nvSpPr>
@@ -16416,6 +17028,10 @@
             <a:prstDash val="solid"/>
           </a:ln>
         </p:spPr>
+        <p:txBody>
+          <a:bodyPr/>
+          <a:p/>
+        </p:txBody>
       </p:sp>
       <p:sp>
         <p:nvSpPr>
@@ -16571,6 +17187,10 @@
             </a:outerShdw>
           </a:effectLst>
         </p:spPr>
+        <p:txBody>
+          <a:bodyPr/>
+          <a:p/>
+        </p:txBody>
       </p:sp>
       <p:sp>
         <p:nvSpPr>
@@ -16602,6 +17222,10 @@
             <a:prstDash val="solid"/>
           </a:ln>
         </p:spPr>
+        <p:txBody>
+          <a:bodyPr/>
+          <a:p/>
+        </p:txBody>
       </p:sp>
       <p:sp>
         <p:nvSpPr>

</xml_diff>